<commit_message>
Edit talk - TODO cherry pick this
</commit_message>
<xml_diff>
--- a/Async Masterclass/Async Masterclass.pptx
+++ b/Async Masterclass/Async Masterclass.pptx
@@ -6,7 +6,7 @@
     <p:sldMasterId id="2147483686" r:id="rId2"/>
   </p:sldMasterIdLst>
   <p:notesMasterIdLst>
-    <p:notesMasterId r:id="rId40"/>
+    <p:notesMasterId r:id="rId41"/>
   </p:notesMasterIdLst>
   <p:sldIdLst>
     <p:sldId id="256" r:id="rId3"/>
@@ -16,36 +16,37 @@
     <p:sldId id="338" r:id="rId7"/>
     <p:sldId id="330" r:id="rId8"/>
     <p:sldId id="339" r:id="rId9"/>
-    <p:sldId id="323" r:id="rId10"/>
-    <p:sldId id="331" r:id="rId11"/>
-    <p:sldId id="359" r:id="rId12"/>
-    <p:sldId id="346" r:id="rId13"/>
-    <p:sldId id="360" r:id="rId14"/>
-    <p:sldId id="324" r:id="rId15"/>
-    <p:sldId id="332" r:id="rId16"/>
-    <p:sldId id="349" r:id="rId17"/>
-    <p:sldId id="345" r:id="rId18"/>
-    <p:sldId id="347" r:id="rId19"/>
-    <p:sldId id="350" r:id="rId20"/>
-    <p:sldId id="325" r:id="rId21"/>
-    <p:sldId id="333" r:id="rId22"/>
-    <p:sldId id="351" r:id="rId23"/>
-    <p:sldId id="326" r:id="rId24"/>
-    <p:sldId id="334" r:id="rId25"/>
-    <p:sldId id="352" r:id="rId26"/>
-    <p:sldId id="353" r:id="rId27"/>
-    <p:sldId id="354" r:id="rId28"/>
-    <p:sldId id="340" r:id="rId29"/>
-    <p:sldId id="327" r:id="rId30"/>
-    <p:sldId id="335" r:id="rId31"/>
-    <p:sldId id="356" r:id="rId32"/>
-    <p:sldId id="355" r:id="rId33"/>
-    <p:sldId id="328" r:id="rId34"/>
-    <p:sldId id="336" r:id="rId35"/>
-    <p:sldId id="358" r:id="rId36"/>
-    <p:sldId id="329" r:id="rId37"/>
-    <p:sldId id="337" r:id="rId38"/>
-    <p:sldId id="274" r:id="rId39"/>
+    <p:sldId id="361" r:id="rId10"/>
+    <p:sldId id="323" r:id="rId11"/>
+    <p:sldId id="331" r:id="rId12"/>
+    <p:sldId id="359" r:id="rId13"/>
+    <p:sldId id="346" r:id="rId14"/>
+    <p:sldId id="360" r:id="rId15"/>
+    <p:sldId id="324" r:id="rId16"/>
+    <p:sldId id="332" r:id="rId17"/>
+    <p:sldId id="349" r:id="rId18"/>
+    <p:sldId id="345" r:id="rId19"/>
+    <p:sldId id="347" r:id="rId20"/>
+    <p:sldId id="350" r:id="rId21"/>
+    <p:sldId id="325" r:id="rId22"/>
+    <p:sldId id="333" r:id="rId23"/>
+    <p:sldId id="351" r:id="rId24"/>
+    <p:sldId id="326" r:id="rId25"/>
+    <p:sldId id="334" r:id="rId26"/>
+    <p:sldId id="352" r:id="rId27"/>
+    <p:sldId id="353" r:id="rId28"/>
+    <p:sldId id="354" r:id="rId29"/>
+    <p:sldId id="340" r:id="rId30"/>
+    <p:sldId id="327" r:id="rId31"/>
+    <p:sldId id="335" r:id="rId32"/>
+    <p:sldId id="356" r:id="rId33"/>
+    <p:sldId id="355" r:id="rId34"/>
+    <p:sldId id="328" r:id="rId35"/>
+    <p:sldId id="336" r:id="rId36"/>
+    <p:sldId id="358" r:id="rId37"/>
+    <p:sldId id="329" r:id="rId38"/>
+    <p:sldId id="337" r:id="rId39"/>
+    <p:sldId id="274" r:id="rId40"/>
   </p:sldIdLst>
   <p:sldSz cx="12192000" cy="6858000"/>
   <p:notesSz cx="6858000" cy="9144000"/>
@@ -234,7 +235,7 @@
           <a:p>
             <a:fld id="{574E8BCA-0B4F-4373-B78E-3D2899449797}" type="datetimeFigureOut">
               <a:rPr lang="en-US" smtClean="0"/>
-              <a:t>5/15/2025</a:t>
+              <a:t>10/24/2026</a:t>
             </a:fld>
             <a:endParaRPr lang="en-US" dirty="0"/>
           </a:p>
@@ -547,13 +548,8 @@
           <a:p>
             <a:r>
               <a:rPr lang="en-US" dirty="0"/>
-              <a:t>Thank you for coming to </a:t>
-            </a:r>
-            <a:r>
-              <a:rPr lang="en-US"/>
-              <a:t>my Thread Talk!</a:t>
-            </a:r>
-            <a:endParaRPr lang="en-US" dirty="0"/>
+              <a:t>Thank you for coming to my Thread Talk!</a:t>
+            </a:r>
           </a:p>
           <a:p>
             <a:endParaRPr lang="en-US" dirty="0"/>
@@ -675,7 +671,7 @@
           <a:p>
             <a:fld id="{94CE3395-F8FF-4336-B2AA-E15575B990E7}" type="slidenum">
               <a:rPr lang="en-US" smtClean="0"/>
-              <a:t>18</a:t>
+              <a:t>19</a:t>
             </a:fld>
             <a:endParaRPr lang="en-US" dirty="0"/>
           </a:p>
@@ -762,7 +758,7 @@
           <a:p>
             <a:fld id="{94CE3395-F8FF-4336-B2AA-E15575B990E7}" type="slidenum">
               <a:rPr lang="en-US" smtClean="0"/>
-              <a:t>21</a:t>
+              <a:t>22</a:t>
             </a:fld>
             <a:endParaRPr lang="en-US" dirty="0"/>
           </a:p>
@@ -846,7 +842,7 @@
           <a:p>
             <a:fld id="{94CE3395-F8FF-4336-B2AA-E15575B990E7}" type="slidenum">
               <a:rPr lang="en-US" smtClean="0"/>
-              <a:t>23</a:t>
+              <a:t>24</a:t>
             </a:fld>
             <a:endParaRPr lang="en-US" dirty="0"/>
           </a:p>
@@ -982,7 +978,7 @@
           <a:p>
             <a:fld id="{94CE3395-F8FF-4336-B2AA-E15575B990E7}" type="slidenum">
               <a:rPr lang="en-US" smtClean="0"/>
-              <a:t>26</a:t>
+              <a:t>27</a:t>
             </a:fld>
             <a:endParaRPr lang="en-US" dirty="0"/>
           </a:p>
@@ -1066,7 +1062,7 @@
           <a:p>
             <a:fld id="{94CE3395-F8FF-4336-B2AA-E15575B990E7}" type="slidenum">
               <a:rPr lang="en-US" smtClean="0"/>
-              <a:t>30</a:t>
+              <a:t>31</a:t>
             </a:fld>
             <a:endParaRPr lang="en-US" dirty="0"/>
           </a:p>
@@ -1526,7 +1522,7 @@
           <a:p>
             <a:fld id="{94CE3395-F8FF-4336-B2AA-E15575B990E7}" type="slidenum">
               <a:rPr lang="en-US" smtClean="0"/>
-              <a:t>33</a:t>
+              <a:t>34</a:t>
             </a:fld>
             <a:endParaRPr lang="en-US" dirty="0"/>
           </a:p>
@@ -1644,7 +1640,7 @@
           <a:p>
             <a:fld id="{94CE3395-F8FF-4336-B2AA-E15575B990E7}" type="slidenum">
               <a:rPr lang="en-US" smtClean="0"/>
-              <a:t>34</a:t>
+              <a:t>35</a:t>
             </a:fld>
             <a:endParaRPr lang="en-US" dirty="0"/>
           </a:p>
@@ -1731,7 +1727,7 @@
           <a:p>
             <a:fld id="{94CE3395-F8FF-4336-B2AA-E15575B990E7}" type="slidenum">
               <a:rPr lang="en-US" smtClean="0"/>
-              <a:t>36</a:t>
+              <a:t>37</a:t>
             </a:fld>
             <a:endParaRPr lang="en-US" dirty="0"/>
           </a:p>
@@ -1815,7 +1811,7 @@
           <a:p>
             <a:fld id="{94CE3395-F8FF-4336-B2AA-E15575B990E7}" type="slidenum">
               <a:rPr lang="en-US" smtClean="0"/>
-              <a:t>37</a:t>
+              <a:t>38</a:t>
             </a:fld>
             <a:endParaRPr lang="en-US" dirty="0"/>
           </a:p>
@@ -2189,7 +2185,7 @@
           <a:p>
             <a:fld id="{94CE3395-F8FF-4336-B2AA-E15575B990E7}" type="slidenum">
               <a:rPr lang="en-US" smtClean="0"/>
-              <a:t>9</a:t>
+              <a:t>10</a:t>
             </a:fld>
             <a:endParaRPr lang="en-US" dirty="0"/>
           </a:p>
@@ -2300,7 +2296,7 @@
           <a:p>
             <a:fld id="{94CE3395-F8FF-4336-B2AA-E15575B990E7}" type="slidenum">
               <a:rPr lang="en-US" smtClean="0"/>
-              <a:t>12</a:t>
+              <a:t>13</a:t>
             </a:fld>
             <a:endParaRPr lang="en-US" dirty="0"/>
           </a:p>
@@ -2398,7 +2394,7 @@
           <a:p>
             <a:fld id="{94CE3395-F8FF-4336-B2AA-E15575B990E7}" type="slidenum">
               <a:rPr lang="en-US" smtClean="0"/>
-              <a:t>14</a:t>
+              <a:t>15</a:t>
             </a:fld>
             <a:endParaRPr lang="en-US" dirty="0"/>
           </a:p>
@@ -2485,7 +2481,7 @@
           <a:p>
             <a:fld id="{94CE3395-F8FF-4336-B2AA-E15575B990E7}" type="slidenum">
               <a:rPr lang="en-US" smtClean="0"/>
-              <a:t>15</a:t>
+              <a:t>16</a:t>
             </a:fld>
             <a:endParaRPr lang="en-US" dirty="0"/>
           </a:p>
@@ -2569,7 +2565,7 @@
           <a:p>
             <a:fld id="{94CE3395-F8FF-4336-B2AA-E15575B990E7}" type="slidenum">
               <a:rPr lang="en-US" smtClean="0"/>
-              <a:t>16</a:t>
+              <a:t>17</a:t>
             </a:fld>
             <a:endParaRPr lang="en-US" dirty="0"/>
           </a:p>
@@ -2653,7 +2649,7 @@
           <a:p>
             <a:fld id="{94CE3395-F8FF-4336-B2AA-E15575B990E7}" type="slidenum">
               <a:rPr lang="en-US" smtClean="0"/>
-              <a:t>17</a:t>
+              <a:t>18</a:t>
             </a:fld>
             <a:endParaRPr lang="en-US" dirty="0"/>
           </a:p>
@@ -4889,6 +4885,190 @@
   <p:cSld>
     <p:spTree>
       <p:nvGrpSpPr>
+        <p:cNvPr id="1" name=""/>
+        <p:cNvGrpSpPr/>
+        <p:nvPr/>
+      </p:nvGrpSpPr>
+      <p:grpSpPr>
+        <a:xfrm>
+          <a:off x="0" y="0"/>
+          <a:ext cx="0" cy="0"/>
+          <a:chOff x="0" y="0"/>
+          <a:chExt cx="0" cy="0"/>
+        </a:xfrm>
+      </p:grpSpPr>
+      <p:sp>
+        <p:nvSpPr>
+          <p:cNvPr id="2" name="Title 1">
+            <a:extLst>
+              <a:ext uri="{FF2B5EF4-FFF2-40B4-BE49-F238E27FC236}">
+                <a16:creationId xmlns:a16="http://schemas.microsoft.com/office/drawing/2014/main" id="{DE2CF484-0F47-554C-2FA2-668360593019}"/>
+              </a:ext>
+            </a:extLst>
+          </p:cNvPr>
+          <p:cNvSpPr>
+            <a:spLocks noGrp="1"/>
+          </p:cNvSpPr>
+          <p:nvPr>
+            <p:ph type="title"/>
+          </p:nvPr>
+        </p:nvSpPr>
+        <p:spPr/>
+        <p:txBody>
+          <a:bodyPr/>
+          <a:lstStyle/>
+          <a:p>
+            <a:r>
+              <a:rPr lang="en-US" dirty="0"/>
+              <a:t>Asynchronous Disposal</a:t>
+            </a:r>
+          </a:p>
+        </p:txBody>
+      </p:sp>
+      <p:sp>
+        <p:nvSpPr>
+          <p:cNvPr id="5" name="Text Placeholder 4">
+            <a:extLst>
+              <a:ext uri="{FF2B5EF4-FFF2-40B4-BE49-F238E27FC236}">
+                <a16:creationId xmlns:a16="http://schemas.microsoft.com/office/drawing/2014/main" id="{BBEE5FCE-DFD3-DCAC-06BC-BF9A8DAF3660}"/>
+              </a:ext>
+            </a:extLst>
+          </p:cNvPr>
+          <p:cNvSpPr>
+            <a:spLocks noGrp="1"/>
+          </p:cNvSpPr>
+          <p:nvPr>
+            <p:ph type="body" sz="quarter" idx="10"/>
+          </p:nvPr>
+        </p:nvSpPr>
+        <p:spPr>
+          <a:xfrm>
+            <a:off x="269239" y="1197322"/>
+            <a:ext cx="11653522" cy="4366708"/>
+          </a:xfrm>
+        </p:spPr>
+        <p:txBody>
+          <a:bodyPr/>
+          <a:lstStyle/>
+          <a:p>
+            <a:r>
+              <a:rPr lang="en-US" dirty="0" err="1">
+                <a:latin typeface="Consolas" panose="020B0609020204030204" pitchFamily="49" charset="0"/>
+              </a:rPr>
+              <a:t>ValueTask</a:t>
+            </a:r>
+            <a:r>
+              <a:rPr lang="en-US" dirty="0">
+                <a:latin typeface="Consolas" panose="020B0609020204030204" pitchFamily="49" charset="0"/>
+              </a:rPr>
+              <a:t> </a:t>
+            </a:r>
+            <a:r>
+              <a:rPr lang="en-US" dirty="0" err="1">
+                <a:latin typeface="Consolas" panose="020B0609020204030204" pitchFamily="49" charset="0"/>
+              </a:rPr>
+              <a:t>DisposeAsync</a:t>
+            </a:r>
+            <a:r>
+              <a:rPr lang="en-US" dirty="0">
+                <a:latin typeface="Consolas" panose="020B0609020204030204" pitchFamily="49" charset="0"/>
+              </a:rPr>
+              <a:t>();</a:t>
+            </a:r>
+          </a:p>
+          <a:p>
+            <a:endParaRPr lang="en-US" dirty="0"/>
+          </a:p>
+          <a:p>
+            <a:pPr marL="457200" indent="-457200">
+              <a:buFontTx/>
+              <a:buChar char="-"/>
+            </a:pPr>
+            <a:r>
+              <a:rPr lang="en-US" dirty="0"/>
+              <a:t>Just like </a:t>
+            </a:r>
+            <a:r>
+              <a:rPr lang="en-US" dirty="0">
+                <a:latin typeface="Consolas" panose="020B0609020204030204" pitchFamily="49" charset="0"/>
+              </a:rPr>
+              <a:t>Dispose()</a:t>
+            </a:r>
+            <a:r>
+              <a:rPr lang="en-US" dirty="0"/>
+              <a:t>, just asynchronous.</a:t>
+            </a:r>
+          </a:p>
+          <a:p>
+            <a:pPr marL="457200" indent="-457200">
+              <a:buFontTx/>
+              <a:buChar char="-"/>
+            </a:pPr>
+            <a:r>
+              <a:rPr lang="en-US" dirty="0"/>
+              <a:t>No official patterns for whether you can (or should) support both, “dispose pattern”, etc.</a:t>
+            </a:r>
+          </a:p>
+          <a:p>
+            <a:pPr marL="457200" indent="-457200">
+              <a:buFontTx/>
+              <a:buChar char="-"/>
+            </a:pPr>
+            <a:endParaRPr lang="en-US" dirty="0"/>
+          </a:p>
+          <a:p>
+            <a:r>
+              <a:rPr lang="en-US" dirty="0"/>
+              <a:t>Not supported everywhere, e.g., </a:t>
+            </a:r>
+            <a:r>
+              <a:rPr lang="en-US" dirty="0" err="1">
+                <a:latin typeface="Consolas" panose="020B0609020204030204" pitchFamily="49" charset="0"/>
+              </a:rPr>
+              <a:t>AsyncServiceScope</a:t>
+            </a:r>
+            <a:r>
+              <a:rPr lang="en-US" dirty="0"/>
+              <a:t> is 6.0+</a:t>
+            </a:r>
+          </a:p>
+          <a:p>
+            <a:pPr marL="457200" indent="-457200">
+              <a:buFontTx/>
+              <a:buChar char="-"/>
+            </a:pPr>
+            <a:r>
+              <a:rPr lang="en-US" dirty="0" err="1"/>
+              <a:t>Nito.Disposables</a:t>
+            </a:r>
+            <a:r>
+              <a:rPr lang="en-US" dirty="0"/>
+              <a:t> if you want helpers.</a:t>
+            </a:r>
+          </a:p>
+        </p:txBody>
+      </p:sp>
+    </p:spTree>
+    <p:extLst>
+      <p:ext uri="{BB962C8B-B14F-4D97-AF65-F5344CB8AC3E}">
+        <p14:creationId xmlns:p14="http://schemas.microsoft.com/office/powerpoint/2010/main" val="658538106"/>
+      </p:ext>
+    </p:extLst>
+  </p:cSld>
+  <p:clrMapOvr>
+    <a:masterClrMapping/>
+  </p:clrMapOvr>
+  <p:transition>
+    <p:fade/>
+  </p:transition>
+</p:sld>
+</file>
+
+<file path=ppt/slides/slide11.xml><?xml version="1.0" encoding="utf-8"?>
+<p:sld xmlns:a="http://schemas.openxmlformats.org/drawingml/2006/main" xmlns:r="http://schemas.openxmlformats.org/officeDocument/2006/relationships" xmlns:p="http://schemas.openxmlformats.org/presentationml/2006/main">
+  <p:cSld>
+    <p:spTree>
+      <p:nvGrpSpPr>
         <p:cNvPr id="1" name="">
           <a:extLst>
             <a:ext uri="{FF2B5EF4-FFF2-40B4-BE49-F238E27FC236}">
@@ -4951,7 +5131,7 @@
 </p:sld>
 </file>
 
-<file path=ppt/slides/slide11.xml><?xml version="1.0" encoding="utf-8"?>
+<file path=ppt/slides/slide12.xml><?xml version="1.0" encoding="utf-8"?>
 <p:sld xmlns:a="http://schemas.openxmlformats.org/drawingml/2006/main" xmlns:r="http://schemas.openxmlformats.org/officeDocument/2006/relationships" xmlns:p="http://schemas.openxmlformats.org/presentationml/2006/main">
   <p:cSld>
     <p:spTree>
@@ -5333,7 +5513,7 @@
 </p:sld>
 </file>
 
-<file path=ppt/slides/slide12.xml><?xml version="1.0" encoding="utf-8"?>
+<file path=ppt/slides/slide13.xml><?xml version="1.0" encoding="utf-8"?>
 <p:sld xmlns:a="http://schemas.openxmlformats.org/drawingml/2006/main" xmlns:r="http://schemas.openxmlformats.org/officeDocument/2006/relationships" xmlns:p="http://schemas.openxmlformats.org/presentationml/2006/main">
   <p:cSld>
     <p:spTree>
@@ -5407,7 +5587,7 @@
 </p:sld>
 </file>
 
-<file path=ppt/slides/slide13.xml><?xml version="1.0" encoding="utf-8"?>
+<file path=ppt/slides/slide14.xml><?xml version="1.0" encoding="utf-8"?>
 <p:sld xmlns:a="http://schemas.openxmlformats.org/drawingml/2006/main" xmlns:r="http://schemas.openxmlformats.org/officeDocument/2006/relationships" xmlns:p="http://schemas.openxmlformats.org/presentationml/2006/main">
   <p:cSld>
     <p:spTree>
@@ -5472,7 +5652,7 @@
 </p:sld>
 </file>
 
-<file path=ppt/slides/slide14.xml><?xml version="1.0" encoding="utf-8"?>
+<file path=ppt/slides/slide15.xml><?xml version="1.0" encoding="utf-8"?>
 <p:sld xmlns:a="http://schemas.openxmlformats.org/drawingml/2006/main" xmlns:r="http://schemas.openxmlformats.org/officeDocument/2006/relationships" xmlns:p="http://schemas.openxmlformats.org/presentationml/2006/main">
   <p:cSld>
     <p:spTree>
@@ -5605,7 +5785,7 @@
 </p:sld>
 </file>
 
-<file path=ppt/slides/slide15.xml><?xml version="1.0" encoding="utf-8"?>
+<file path=ppt/slides/slide16.xml><?xml version="1.0" encoding="utf-8"?>
 <p:sld xmlns:a="http://schemas.openxmlformats.org/drawingml/2006/main" xmlns:r="http://schemas.openxmlformats.org/officeDocument/2006/relationships" xmlns:p="http://schemas.openxmlformats.org/presentationml/2006/main">
   <p:cSld>
     <p:spTree>
@@ -5828,7 +6008,7 @@
 </p:sld>
 </file>
 
-<file path=ppt/slides/slide16.xml><?xml version="1.0" encoding="utf-8"?>
+<file path=ppt/slides/slide17.xml><?xml version="1.0" encoding="utf-8"?>
 <p:sld xmlns:a="http://schemas.openxmlformats.org/drawingml/2006/main" xmlns:r="http://schemas.openxmlformats.org/officeDocument/2006/relationships" xmlns:p="http://schemas.openxmlformats.org/presentationml/2006/main">
   <p:cSld>
     <p:spTree>
@@ -6069,7 +6249,7 @@
 </p:sld>
 </file>
 
-<file path=ppt/slides/slide17.xml><?xml version="1.0" encoding="utf-8"?>
+<file path=ppt/slides/slide18.xml><?xml version="1.0" encoding="utf-8"?>
 <p:sld xmlns:a="http://schemas.openxmlformats.org/drawingml/2006/main" xmlns:r="http://schemas.openxmlformats.org/officeDocument/2006/relationships" xmlns:p="http://schemas.openxmlformats.org/presentationml/2006/main">
   <p:cSld>
     <p:spTree>
@@ -6214,160 +6394,6 @@
 </p:sld>
 </file>
 
-<file path=ppt/slides/slide18.xml><?xml version="1.0" encoding="utf-8"?>
-<p:sld xmlns:a="http://schemas.openxmlformats.org/drawingml/2006/main" xmlns:r="http://schemas.openxmlformats.org/officeDocument/2006/relationships" xmlns:p="http://schemas.openxmlformats.org/presentationml/2006/main">
-  <p:cSld>
-    <p:spTree>
-      <p:nvGrpSpPr>
-        <p:cNvPr id="1" name=""/>
-        <p:cNvGrpSpPr/>
-        <p:nvPr/>
-      </p:nvGrpSpPr>
-      <p:grpSpPr>
-        <a:xfrm>
-          <a:off x="0" y="0"/>
-          <a:ext cx="0" cy="0"/>
-          <a:chOff x="0" y="0"/>
-          <a:chExt cx="0" cy="0"/>
-        </a:xfrm>
-      </p:grpSpPr>
-      <p:sp>
-        <p:nvSpPr>
-          <p:cNvPr id="3" name="Title 2">
-            <a:extLst>
-              <a:ext uri="{FF2B5EF4-FFF2-40B4-BE49-F238E27FC236}">
-                <a16:creationId xmlns:a16="http://schemas.microsoft.com/office/drawing/2014/main" id="{C8B1BACE-61A4-9E5D-BCE5-61F358F5296A}"/>
-              </a:ext>
-            </a:extLst>
-          </p:cNvPr>
-          <p:cNvSpPr>
-            <a:spLocks noGrp="1"/>
-          </p:cNvSpPr>
-          <p:nvPr>
-            <p:ph type="title"/>
-          </p:nvPr>
-        </p:nvSpPr>
-        <p:spPr/>
-        <p:txBody>
-          <a:bodyPr/>
-          <a:lstStyle/>
-          <a:p>
-            <a:r>
-              <a:rPr lang="en-US" dirty="0" err="1"/>
-              <a:t>AsyncLocal</a:t>
-            </a:r>
-            <a:r>
-              <a:rPr lang="en-US" dirty="0"/>
-              <a:t>: Primary Use Case: Pitfall</a:t>
-            </a:r>
-          </a:p>
-        </p:txBody>
-      </p:sp>
-      <p:sp>
-        <p:nvSpPr>
-          <p:cNvPr id="4" name="Text Placeholder 3">
-            <a:extLst>
-              <a:ext uri="{FF2B5EF4-FFF2-40B4-BE49-F238E27FC236}">
-                <a16:creationId xmlns:a16="http://schemas.microsoft.com/office/drawing/2014/main" id="{55DF523C-7CBA-46DD-7A41-0B1737344545}"/>
-              </a:ext>
-            </a:extLst>
-          </p:cNvPr>
-          <p:cNvSpPr>
-            <a:spLocks noGrp="1"/>
-          </p:cNvSpPr>
-          <p:nvPr>
-            <p:ph type="body" sz="quarter" idx="10"/>
-          </p:nvPr>
-        </p:nvSpPr>
-        <p:spPr>
-          <a:xfrm>
-            <a:off x="269239" y="1197322"/>
-            <a:ext cx="11653522" cy="3918637"/>
-          </a:xfrm>
-        </p:spPr>
-        <p:txBody>
-          <a:bodyPr/>
-          <a:lstStyle/>
-          <a:p>
-            <a:r>
-              <a:rPr lang="en-US" dirty="0"/>
-              <a:t>Exception logging </a:t>
-            </a:r>
-            <a:r>
-              <a:rPr lang="en-US"/>
-              <a:t>missing contextual data.</a:t>
-            </a:r>
-            <a:endParaRPr lang="en-US" dirty="0"/>
-          </a:p>
-          <a:p>
-            <a:pPr marL="457200" indent="-457200">
-              <a:buFontTx/>
-              <a:buChar char="-"/>
-            </a:pPr>
-            <a:endParaRPr lang="en-US" dirty="0"/>
-          </a:p>
-          <a:p>
-            <a:pPr marL="457200" indent="-457200">
-              <a:buFontTx/>
-              <a:buChar char="-"/>
-            </a:pPr>
-            <a:r>
-              <a:rPr lang="en-US" dirty="0"/>
-              <a:t>How does ASP.NET middleware actually work?</a:t>
-            </a:r>
-          </a:p>
-          <a:p>
-            <a:pPr marL="457200" indent="-457200">
-              <a:buFontTx/>
-              <a:buChar char="-"/>
-            </a:pPr>
-            <a:endParaRPr lang="en-US" dirty="0"/>
-          </a:p>
-          <a:p>
-            <a:pPr marL="457200" indent="-457200">
-              <a:buFontTx/>
-              <a:buChar char="-"/>
-            </a:pPr>
-            <a:r>
-              <a:rPr lang="en-US" dirty="0"/>
-              <a:t>How does exception logging middleware work?</a:t>
-            </a:r>
-          </a:p>
-          <a:p>
-            <a:pPr marL="457200" indent="-457200">
-              <a:buFontTx/>
-              <a:buChar char="-"/>
-            </a:pPr>
-            <a:endParaRPr lang="en-US" dirty="0"/>
-          </a:p>
-          <a:p>
-            <a:pPr marL="457200" indent="-457200">
-              <a:buFontTx/>
-              <a:buChar char="-"/>
-            </a:pPr>
-            <a:r>
-              <a:rPr lang="en-US" dirty="0"/>
-              <a:t>Solution: throw context enrichers.</a:t>
-            </a:r>
-          </a:p>
-        </p:txBody>
-      </p:sp>
-    </p:spTree>
-    <p:extLst>
-      <p:ext uri="{BB962C8B-B14F-4D97-AF65-F5344CB8AC3E}">
-        <p14:creationId xmlns:p14="http://schemas.microsoft.com/office/powerpoint/2010/main" val="3421048878"/>
-      </p:ext>
-    </p:extLst>
-  </p:cSld>
-  <p:clrMapOvr>
-    <a:masterClrMapping/>
-  </p:clrMapOvr>
-  <p:transition>
-    <p:fade/>
-  </p:transition>
-</p:sld>
-</file>
-
 <file path=ppt/slides/slide19.xml><?xml version="1.0" encoding="utf-8"?>
 <p:sld xmlns:a="http://schemas.openxmlformats.org/drawingml/2006/main" xmlns:r="http://schemas.openxmlformats.org/officeDocument/2006/relationships" xmlns:p="http://schemas.openxmlformats.org/presentationml/2006/main">
   <p:cSld>
@@ -6387,10 +6413,10 @@
       </p:grpSpPr>
       <p:sp>
         <p:nvSpPr>
-          <p:cNvPr id="2" name="Title 1">
+          <p:cNvPr id="3" name="Title 2">
             <a:extLst>
               <a:ext uri="{FF2B5EF4-FFF2-40B4-BE49-F238E27FC236}">
-                <a16:creationId xmlns:a16="http://schemas.microsoft.com/office/drawing/2014/main" id="{47C1EC8D-C869-4A7A-8349-D1F62555E0F7}"/>
+                <a16:creationId xmlns:a16="http://schemas.microsoft.com/office/drawing/2014/main" id="{C8B1BACE-61A4-9E5D-BCE5-61F358F5296A}"/>
               </a:ext>
             </a:extLst>
           </p:cNvPr>
@@ -6407,8 +6433,101 @@
           <a:lstStyle/>
           <a:p>
             <a:r>
-              <a:rPr lang="en-US" dirty="0"/>
-              <a:t>Channels</a:t>
+              <a:rPr lang="en-US" dirty="0" err="1"/>
+              <a:t>AsyncLocal</a:t>
+            </a:r>
+            <a:r>
+              <a:rPr lang="en-US" dirty="0"/>
+              <a:t>: Primary Use Case: Pitfall</a:t>
+            </a:r>
+          </a:p>
+        </p:txBody>
+      </p:sp>
+      <p:sp>
+        <p:nvSpPr>
+          <p:cNvPr id="4" name="Text Placeholder 3">
+            <a:extLst>
+              <a:ext uri="{FF2B5EF4-FFF2-40B4-BE49-F238E27FC236}">
+                <a16:creationId xmlns:a16="http://schemas.microsoft.com/office/drawing/2014/main" id="{55DF523C-7CBA-46DD-7A41-0B1737344545}"/>
+              </a:ext>
+            </a:extLst>
+          </p:cNvPr>
+          <p:cNvSpPr>
+            <a:spLocks noGrp="1"/>
+          </p:cNvSpPr>
+          <p:nvPr>
+            <p:ph type="body" sz="quarter" idx="10"/>
+          </p:nvPr>
+        </p:nvSpPr>
+        <p:spPr>
+          <a:xfrm>
+            <a:off x="269239" y="1197322"/>
+            <a:ext cx="11653522" cy="3918637"/>
+          </a:xfrm>
+        </p:spPr>
+        <p:txBody>
+          <a:bodyPr/>
+          <a:lstStyle/>
+          <a:p>
+            <a:r>
+              <a:rPr lang="en-US" dirty="0"/>
+              <a:t>Exception logging </a:t>
+            </a:r>
+            <a:r>
+              <a:rPr lang="en-US"/>
+              <a:t>missing contextual data.</a:t>
+            </a:r>
+            <a:endParaRPr lang="en-US" dirty="0"/>
+          </a:p>
+          <a:p>
+            <a:pPr marL="457200" indent="-457200">
+              <a:buFontTx/>
+              <a:buChar char="-"/>
+            </a:pPr>
+            <a:endParaRPr lang="en-US" dirty="0"/>
+          </a:p>
+          <a:p>
+            <a:pPr marL="457200" indent="-457200">
+              <a:buFontTx/>
+              <a:buChar char="-"/>
+            </a:pPr>
+            <a:r>
+              <a:rPr lang="en-US" dirty="0"/>
+              <a:t>How does ASP.NET middleware actually work?</a:t>
+            </a:r>
+          </a:p>
+          <a:p>
+            <a:pPr marL="457200" indent="-457200">
+              <a:buFontTx/>
+              <a:buChar char="-"/>
+            </a:pPr>
+            <a:endParaRPr lang="en-US" dirty="0"/>
+          </a:p>
+          <a:p>
+            <a:pPr marL="457200" indent="-457200">
+              <a:buFontTx/>
+              <a:buChar char="-"/>
+            </a:pPr>
+            <a:r>
+              <a:rPr lang="en-US" dirty="0"/>
+              <a:t>How does exception logging middleware work?</a:t>
+            </a:r>
+          </a:p>
+          <a:p>
+            <a:pPr marL="457200" indent="-457200">
+              <a:buFontTx/>
+              <a:buChar char="-"/>
+            </a:pPr>
+            <a:endParaRPr lang="en-US" dirty="0"/>
+          </a:p>
+          <a:p>
+            <a:pPr marL="457200" indent="-457200">
+              <a:buFontTx/>
+              <a:buChar char="-"/>
+            </a:pPr>
+            <a:r>
+              <a:rPr lang="en-US" dirty="0"/>
+              <a:t>Solution: throw context enrichers.</a:t>
             </a:r>
           </a:p>
         </p:txBody>
@@ -6416,7 +6535,7 @@
     </p:spTree>
     <p:extLst>
       <p:ext uri="{BB962C8B-B14F-4D97-AF65-F5344CB8AC3E}">
-        <p14:creationId xmlns:p14="http://schemas.microsoft.com/office/powerpoint/2010/main" val="1959425526"/>
+        <p14:creationId xmlns:p14="http://schemas.microsoft.com/office/powerpoint/2010/main" val="3421048878"/>
       </p:ext>
     </p:extLst>
   </p:cSld>
@@ -6567,6 +6686,67 @@
       </p:grpSpPr>
       <p:sp>
         <p:nvSpPr>
+          <p:cNvPr id="2" name="Title 1">
+            <a:extLst>
+              <a:ext uri="{FF2B5EF4-FFF2-40B4-BE49-F238E27FC236}">
+                <a16:creationId xmlns:a16="http://schemas.microsoft.com/office/drawing/2014/main" id="{47C1EC8D-C869-4A7A-8349-D1F62555E0F7}"/>
+              </a:ext>
+            </a:extLst>
+          </p:cNvPr>
+          <p:cNvSpPr>
+            <a:spLocks noGrp="1"/>
+          </p:cNvSpPr>
+          <p:nvPr>
+            <p:ph type="title"/>
+          </p:nvPr>
+        </p:nvSpPr>
+        <p:spPr/>
+        <p:txBody>
+          <a:bodyPr/>
+          <a:lstStyle/>
+          <a:p>
+            <a:r>
+              <a:rPr lang="en-US" dirty="0"/>
+              <a:t>Channels</a:t>
+            </a:r>
+          </a:p>
+        </p:txBody>
+      </p:sp>
+    </p:spTree>
+    <p:extLst>
+      <p:ext uri="{BB962C8B-B14F-4D97-AF65-F5344CB8AC3E}">
+        <p14:creationId xmlns:p14="http://schemas.microsoft.com/office/powerpoint/2010/main" val="1959425526"/>
+      </p:ext>
+    </p:extLst>
+  </p:cSld>
+  <p:clrMapOvr>
+    <a:masterClrMapping/>
+  </p:clrMapOvr>
+  <p:transition>
+    <p:fade/>
+  </p:transition>
+</p:sld>
+</file>
+
+<file path=ppt/slides/slide21.xml><?xml version="1.0" encoding="utf-8"?>
+<p:sld xmlns:a="http://schemas.openxmlformats.org/drawingml/2006/main" xmlns:r="http://schemas.openxmlformats.org/officeDocument/2006/relationships" xmlns:p="http://schemas.openxmlformats.org/presentationml/2006/main">
+  <p:cSld>
+    <p:spTree>
+      <p:nvGrpSpPr>
+        <p:cNvPr id="1" name=""/>
+        <p:cNvGrpSpPr/>
+        <p:nvPr/>
+      </p:nvGrpSpPr>
+      <p:grpSpPr>
+        <a:xfrm>
+          <a:off x="0" y="0"/>
+          <a:ext cx="0" cy="0"/>
+          <a:chOff x="0" y="0"/>
+          <a:chExt cx="0" cy="0"/>
+        </a:xfrm>
+      </p:grpSpPr>
+      <p:sp>
+        <p:nvSpPr>
           <p:cNvPr id="3" name="Title 2">
             <a:extLst>
               <a:ext uri="{FF2B5EF4-FFF2-40B4-BE49-F238E27FC236}">
@@ -6699,7 +6879,7 @@
 </p:sld>
 </file>
 
-<file path=ppt/slides/slide21.xml><?xml version="1.0" encoding="utf-8"?>
+<file path=ppt/slides/slide22.xml><?xml version="1.0" encoding="utf-8"?>
 <p:sld xmlns:a="http://schemas.openxmlformats.org/drawingml/2006/main" xmlns:r="http://schemas.openxmlformats.org/officeDocument/2006/relationships" xmlns:p="http://schemas.openxmlformats.org/presentationml/2006/main">
   <p:cSld>
     <p:spTree>
@@ -6767,7 +6947,7 @@
 </p:sld>
 </file>
 
-<file path=ppt/slides/slide22.xml><?xml version="1.0" encoding="utf-8"?>
+<file path=ppt/slides/slide23.xml><?xml version="1.0" encoding="utf-8"?>
 <p:sld xmlns:a="http://schemas.openxmlformats.org/drawingml/2006/main" xmlns:r="http://schemas.openxmlformats.org/officeDocument/2006/relationships" xmlns:p="http://schemas.openxmlformats.org/presentationml/2006/main">
   <p:cSld>
     <p:spTree>
@@ -6829,7 +7009,7 @@
 </p:sld>
 </file>
 
-<file path=ppt/slides/slide23.xml><?xml version="1.0" encoding="utf-8"?>
+<file path=ppt/slides/slide24.xml><?xml version="1.0" encoding="utf-8"?>
 <p:sld xmlns:a="http://schemas.openxmlformats.org/drawingml/2006/main" xmlns:r="http://schemas.openxmlformats.org/officeDocument/2006/relationships" xmlns:p="http://schemas.openxmlformats.org/presentationml/2006/main">
   <p:cSld>
     <p:spTree>
@@ -7004,7 +7184,7 @@
 </p:sld>
 </file>
 
-<file path=ppt/slides/slide24.xml><?xml version="1.0" encoding="utf-8"?>
+<file path=ppt/slides/slide25.xml><?xml version="1.0" encoding="utf-8"?>
 <p:sld xmlns:a="http://schemas.openxmlformats.org/drawingml/2006/main" xmlns:r="http://schemas.openxmlformats.org/officeDocument/2006/relationships" xmlns:p="http://schemas.openxmlformats.org/presentationml/2006/main">
   <p:cSld>
     <p:spTree>
@@ -7180,7 +7360,7 @@
 </p:sld>
 </file>
 
-<file path=ppt/slides/slide25.xml><?xml version="1.0" encoding="utf-8"?>
+<file path=ppt/slides/slide26.xml><?xml version="1.0" encoding="utf-8"?>
 <p:sld xmlns:a="http://schemas.openxmlformats.org/drawingml/2006/main" xmlns:r="http://schemas.openxmlformats.org/officeDocument/2006/relationships" xmlns:p="http://schemas.openxmlformats.org/presentationml/2006/main">
   <p:cSld>
     <p:spTree>
@@ -7480,7 +7660,7 @@
 </p:sld>
 </file>
 
-<file path=ppt/slides/slide26.xml><?xml version="1.0" encoding="utf-8"?>
+<file path=ppt/slides/slide27.xml><?xml version="1.0" encoding="utf-8"?>
 <p:sld xmlns:a="http://schemas.openxmlformats.org/drawingml/2006/main" xmlns:r="http://schemas.openxmlformats.org/officeDocument/2006/relationships" xmlns:p="http://schemas.openxmlformats.org/presentationml/2006/main">
   <p:cSld>
     <p:spTree>
@@ -7548,170 +7728,6 @@
 </p:sld>
 </file>
 
-<file path=ppt/slides/slide27.xml><?xml version="1.0" encoding="utf-8"?>
-<p:sld xmlns:a="http://schemas.openxmlformats.org/drawingml/2006/main" xmlns:r="http://schemas.openxmlformats.org/officeDocument/2006/relationships" xmlns:p="http://schemas.openxmlformats.org/presentationml/2006/main">
-  <p:cSld>
-    <p:spTree>
-      <p:nvGrpSpPr>
-        <p:cNvPr id="1" name=""/>
-        <p:cNvGrpSpPr/>
-        <p:nvPr/>
-      </p:nvGrpSpPr>
-      <p:grpSpPr>
-        <a:xfrm>
-          <a:off x="0" y="0"/>
-          <a:ext cx="0" cy="0"/>
-          <a:chOff x="0" y="0"/>
-          <a:chExt cx="0" cy="0"/>
-        </a:xfrm>
-      </p:grpSpPr>
-      <p:sp>
-        <p:nvSpPr>
-          <p:cNvPr id="2" name="Title 1">
-            <a:extLst>
-              <a:ext uri="{FF2B5EF4-FFF2-40B4-BE49-F238E27FC236}">
-                <a16:creationId xmlns:a16="http://schemas.microsoft.com/office/drawing/2014/main" id="{2117C7E0-D93C-8C61-E1C7-250A794B4116}"/>
-              </a:ext>
-            </a:extLst>
-          </p:cNvPr>
-          <p:cNvSpPr>
-            <a:spLocks noGrp="1"/>
-          </p:cNvSpPr>
-          <p:nvPr>
-            <p:ph type="title"/>
-          </p:nvPr>
-        </p:nvSpPr>
-        <p:spPr/>
-        <p:txBody>
-          <a:bodyPr/>
-          <a:lstStyle/>
-          <a:p>
-            <a:r>
-              <a:rPr lang="en-US" dirty="0" err="1"/>
-              <a:t>PauseToken</a:t>
-            </a:r>
-            <a:r>
-              <a:rPr lang="en-US" dirty="0"/>
-              <a:t> Implementation</a:t>
-            </a:r>
-          </a:p>
-        </p:txBody>
-      </p:sp>
-      <p:sp>
-        <p:nvSpPr>
-          <p:cNvPr id="3" name="Text Placeholder 2">
-            <a:extLst>
-              <a:ext uri="{FF2B5EF4-FFF2-40B4-BE49-F238E27FC236}">
-                <a16:creationId xmlns:a16="http://schemas.microsoft.com/office/drawing/2014/main" id="{FA1B9A00-2629-4390-1F99-F8ADE5462A74}"/>
-              </a:ext>
-            </a:extLst>
-          </p:cNvPr>
-          <p:cNvSpPr>
-            <a:spLocks noGrp="1"/>
-          </p:cNvSpPr>
-          <p:nvPr>
-            <p:ph type="body" sz="quarter" idx="10"/>
-          </p:nvPr>
-        </p:nvSpPr>
-        <p:spPr>
-          <a:xfrm>
-            <a:off x="269239" y="1197322"/>
-            <a:ext cx="11653522" cy="3719480"/>
-          </a:xfrm>
-        </p:spPr>
-        <p:txBody>
-          <a:bodyPr/>
-          <a:lstStyle/>
-          <a:p>
-            <a:r>
-              <a:rPr lang="en-US" dirty="0"/>
-              <a:t>Tricksy parts:</a:t>
-            </a:r>
-          </a:p>
-          <a:p>
-            <a:pPr marL="457200" indent="-457200">
-              <a:buFontTx/>
-              <a:buChar char="-"/>
-            </a:pPr>
-            <a:endParaRPr lang="en-US" b="1" dirty="0"/>
-          </a:p>
-          <a:p>
-            <a:pPr marL="457200" indent="-457200">
-              <a:buFontTx/>
-              <a:buChar char="-"/>
-            </a:pPr>
-            <a:r>
-              <a:rPr lang="en-US" b="1" dirty="0"/>
-              <a:t>Never invoke end-user code while holding a lock.</a:t>
-            </a:r>
-          </a:p>
-          <a:p>
-            <a:pPr marL="457200" indent="-457200">
-              <a:buFontTx/>
-              <a:buChar char="-"/>
-            </a:pPr>
-            <a:endParaRPr lang="en-US" b="1" dirty="0"/>
-          </a:p>
-          <a:p>
-            <a:pPr marL="457200" indent="-457200">
-              <a:buFontTx/>
-              <a:buChar char="-"/>
-            </a:pPr>
-            <a:r>
-              <a:rPr lang="en-US" dirty="0" err="1">
-                <a:latin typeface="Consolas" panose="020B0609020204030204" pitchFamily="49" charset="0"/>
-              </a:rPr>
-              <a:t>TaskCompletionSource.TrySetResult</a:t>
-            </a:r>
-            <a:r>
-              <a:rPr lang="en-US" dirty="0">
-                <a:latin typeface="Consolas" panose="020B0609020204030204" pitchFamily="49" charset="0"/>
-              </a:rPr>
-              <a:t> </a:t>
-            </a:r>
-            <a:r>
-              <a:rPr lang="en-US" dirty="0"/>
-              <a:t>(and friends) and </a:t>
-            </a:r>
-            <a:r>
-              <a:rPr lang="en-US" dirty="0" err="1">
-                <a:latin typeface="Consolas" panose="020B0609020204030204" pitchFamily="49" charset="0"/>
-              </a:rPr>
-              <a:t>CancellationTokenSource.Cancel</a:t>
-            </a:r>
-            <a:r>
-              <a:rPr lang="en-US" dirty="0">
-                <a:latin typeface="Consolas" panose="020B0609020204030204" pitchFamily="49" charset="0"/>
-              </a:rPr>
-              <a:t> </a:t>
-            </a:r>
-            <a:r>
-              <a:rPr lang="en-US" i="1" dirty="0"/>
-              <a:t>are</a:t>
-            </a:r>
-            <a:r>
-              <a:rPr lang="en-US" dirty="0"/>
-              <a:t> invocations of end-user code!</a:t>
-            </a:r>
-          </a:p>
-        </p:txBody>
-      </p:sp>
-    </p:spTree>
-    <p:extLst>
-      <p:ext uri="{BB962C8B-B14F-4D97-AF65-F5344CB8AC3E}">
-        <p14:creationId xmlns:p14="http://schemas.microsoft.com/office/powerpoint/2010/main" val="1966586368"/>
-      </p:ext>
-    </p:extLst>
-  </p:cSld>
-  <p:clrMapOvr>
-    <a:masterClrMapping/>
-  </p:clrMapOvr>
-  <p:transition>
-    <p:fade/>
-  </p:transition>
-</p:sld>
-</file>
-
 <file path=ppt/slides/slide28.xml><?xml version="1.0" encoding="utf-8"?>
 <p:sld xmlns:a="http://schemas.openxmlformats.org/drawingml/2006/main" xmlns:r="http://schemas.openxmlformats.org/officeDocument/2006/relationships" xmlns:p="http://schemas.openxmlformats.org/presentationml/2006/main">
   <p:cSld>
@@ -7734,7 +7750,7 @@
           <p:cNvPr id="2" name="Title 1">
             <a:extLst>
               <a:ext uri="{FF2B5EF4-FFF2-40B4-BE49-F238E27FC236}">
-                <a16:creationId xmlns:a16="http://schemas.microsoft.com/office/drawing/2014/main" id="{47C1EC8D-C869-4A7A-8349-D1F62555E0F7}"/>
+                <a16:creationId xmlns:a16="http://schemas.microsoft.com/office/drawing/2014/main" id="{2117C7E0-D93C-8C61-E1C7-250A794B4116}"/>
               </a:ext>
             </a:extLst>
           </p:cNvPr>
@@ -7751,8 +7767,111 @@
           <a:lstStyle/>
           <a:p>
             <a:r>
-              <a:rPr lang="en-US" dirty="0"/>
-              <a:t>TCS Dictionary</a:t>
+              <a:rPr lang="en-US" dirty="0" err="1"/>
+              <a:t>PauseToken</a:t>
+            </a:r>
+            <a:r>
+              <a:rPr lang="en-US" dirty="0"/>
+              <a:t> Implementation</a:t>
+            </a:r>
+          </a:p>
+        </p:txBody>
+      </p:sp>
+      <p:sp>
+        <p:nvSpPr>
+          <p:cNvPr id="3" name="Text Placeholder 2">
+            <a:extLst>
+              <a:ext uri="{FF2B5EF4-FFF2-40B4-BE49-F238E27FC236}">
+                <a16:creationId xmlns:a16="http://schemas.microsoft.com/office/drawing/2014/main" id="{FA1B9A00-2629-4390-1F99-F8ADE5462A74}"/>
+              </a:ext>
+            </a:extLst>
+          </p:cNvPr>
+          <p:cNvSpPr>
+            <a:spLocks noGrp="1"/>
+          </p:cNvSpPr>
+          <p:nvPr>
+            <p:ph type="body" sz="quarter" idx="10"/>
+          </p:nvPr>
+        </p:nvSpPr>
+        <p:spPr>
+          <a:xfrm>
+            <a:off x="269239" y="1197322"/>
+            <a:ext cx="11653522" cy="3719480"/>
+          </a:xfrm>
+        </p:spPr>
+        <p:txBody>
+          <a:bodyPr/>
+          <a:lstStyle/>
+          <a:p>
+            <a:r>
+              <a:rPr lang="en-US" dirty="0"/>
+              <a:t>Tricksy parts:</a:t>
+            </a:r>
+          </a:p>
+          <a:p>
+            <a:pPr marL="457200" indent="-457200">
+              <a:buFontTx/>
+              <a:buChar char="-"/>
+            </a:pPr>
+            <a:endParaRPr lang="en-US" b="1" dirty="0"/>
+          </a:p>
+          <a:p>
+            <a:pPr marL="457200" indent="-457200">
+              <a:buFontTx/>
+              <a:buChar char="-"/>
+            </a:pPr>
+            <a:r>
+              <a:rPr lang="en-US" b="1" dirty="0"/>
+              <a:t>Never invoke end-user code while holding a lock.</a:t>
+            </a:r>
+          </a:p>
+          <a:p>
+            <a:pPr marL="457200" indent="-457200">
+              <a:buFontTx/>
+              <a:buChar char="-"/>
+            </a:pPr>
+            <a:endParaRPr lang="en-US" b="1" dirty="0"/>
+          </a:p>
+          <a:p>
+            <a:pPr marL="457200" indent="-457200">
+              <a:buFontTx/>
+              <a:buChar char="-"/>
+            </a:pPr>
+            <a:r>
+              <a:rPr lang="en-US" dirty="0" err="1">
+                <a:latin typeface="Consolas" panose="020B0609020204030204" pitchFamily="49" charset="0"/>
+              </a:rPr>
+              <a:t>TaskCompletionSource.TrySetResult</a:t>
+            </a:r>
+            <a:r>
+              <a:rPr lang="en-US" dirty="0">
+                <a:latin typeface="Consolas" panose="020B0609020204030204" pitchFamily="49" charset="0"/>
+              </a:rPr>
+              <a:t> </a:t>
+            </a:r>
+            <a:r>
+              <a:rPr lang="en-US" dirty="0"/>
+              <a:t>(and friends) and </a:t>
+            </a:r>
+            <a:r>
+              <a:rPr lang="en-US" dirty="0" err="1">
+                <a:latin typeface="Consolas" panose="020B0609020204030204" pitchFamily="49" charset="0"/>
+              </a:rPr>
+              <a:t>CancellationTokenSource.Cancel</a:t>
+            </a:r>
+            <a:r>
+              <a:rPr lang="en-US" dirty="0">
+                <a:latin typeface="Consolas" panose="020B0609020204030204" pitchFamily="49" charset="0"/>
+              </a:rPr>
+              <a:t> </a:t>
+            </a:r>
+            <a:r>
+              <a:rPr lang="en-US" i="1" dirty="0"/>
+              <a:t>are</a:t>
+            </a:r>
+            <a:r>
+              <a:rPr lang="en-US" dirty="0"/>
+              <a:t> invocations of end-user code!</a:t>
             </a:r>
           </a:p>
         </p:txBody>
@@ -7760,7 +7879,7 @@
     </p:spTree>
     <p:extLst>
       <p:ext uri="{BB962C8B-B14F-4D97-AF65-F5344CB8AC3E}">
-        <p14:creationId xmlns:p14="http://schemas.microsoft.com/office/powerpoint/2010/main" val="3461717117"/>
+        <p14:creationId xmlns:p14="http://schemas.microsoft.com/office/powerpoint/2010/main" val="1966586368"/>
       </p:ext>
     </p:extLst>
   </p:cSld>
@@ -7792,10 +7911,10 @@
       </p:grpSpPr>
       <p:sp>
         <p:nvSpPr>
-          <p:cNvPr id="3" name="Title 2">
+          <p:cNvPr id="2" name="Title 1">
             <a:extLst>
               <a:ext uri="{FF2B5EF4-FFF2-40B4-BE49-F238E27FC236}">
-                <a16:creationId xmlns:a16="http://schemas.microsoft.com/office/drawing/2014/main" id="{839DED77-AC07-8439-3D65-A59625B6AC1F}"/>
+                <a16:creationId xmlns:a16="http://schemas.microsoft.com/office/drawing/2014/main" id="{47C1EC8D-C869-4A7A-8349-D1F62555E0F7}"/>
               </a:ext>
             </a:extLst>
           </p:cNvPr>
@@ -7813,67 +7932,7 @@
           <a:p>
             <a:r>
               <a:rPr lang="en-US" dirty="0"/>
-              <a:t>TCS Dictionary: Desired Semantics</a:t>
-            </a:r>
-          </a:p>
-        </p:txBody>
-      </p:sp>
-      <p:sp>
-        <p:nvSpPr>
-          <p:cNvPr id="4" name="Text Placeholder 3">
-            <a:extLst>
-              <a:ext uri="{FF2B5EF4-FFF2-40B4-BE49-F238E27FC236}">
-                <a16:creationId xmlns:a16="http://schemas.microsoft.com/office/drawing/2014/main" id="{575DA4B2-2627-1440-2751-387E8A17F5BB}"/>
-              </a:ext>
-            </a:extLst>
-          </p:cNvPr>
-          <p:cNvSpPr>
-            <a:spLocks noGrp="1"/>
-          </p:cNvSpPr>
-          <p:nvPr>
-            <p:ph type="body" sz="quarter" idx="10"/>
-          </p:nvPr>
-        </p:nvSpPr>
-        <p:spPr>
-          <a:xfrm>
-            <a:off x="269239" y="1197322"/>
-            <a:ext cx="11653522" cy="4366708"/>
-          </a:xfrm>
-        </p:spPr>
-        <p:txBody>
-          <a:bodyPr/>
-          <a:lstStyle/>
-          <a:p>
-            <a:r>
-              <a:rPr lang="en-US" dirty="0"/>
-              <a:t>Common situation: multiple requests and replies, where replies may not be in request order.</a:t>
-            </a:r>
-          </a:p>
-          <a:p>
-            <a:endParaRPr lang="en-US" dirty="0"/>
-          </a:p>
-          <a:p>
-            <a:r>
-              <a:rPr lang="en-US" dirty="0"/>
-              <a:t>Solution: TCS dictionary.</a:t>
-            </a:r>
-          </a:p>
-          <a:p>
-            <a:endParaRPr lang="en-US" dirty="0"/>
-          </a:p>
-          <a:p>
-            <a:r>
-              <a:rPr lang="en-US" dirty="0"/>
-              <a:t>Operations: Insert, Remove-And-Complete.</a:t>
-            </a:r>
-          </a:p>
-          <a:p>
-            <a:endParaRPr lang="en-US" dirty="0"/>
-          </a:p>
-          <a:p>
-            <a:r>
-              <a:rPr lang="en-US" b="1" dirty="0"/>
-              <a:t>Always complete your tasks!</a:t>
+              <a:t>TCS Dictionary</a:t>
             </a:r>
           </a:p>
         </p:txBody>
@@ -7881,7 +7940,7 @@
     </p:spTree>
     <p:extLst>
       <p:ext uri="{BB962C8B-B14F-4D97-AF65-F5344CB8AC3E}">
-        <p14:creationId xmlns:p14="http://schemas.microsoft.com/office/powerpoint/2010/main" val="1175680737"/>
+        <p14:creationId xmlns:p14="http://schemas.microsoft.com/office/powerpoint/2010/main" val="3461717117"/>
       </p:ext>
     </p:extLst>
   </p:cSld>
@@ -7973,6 +8032,127 @@
           <a:chExt cx="0" cy="0"/>
         </a:xfrm>
       </p:grpSpPr>
+      <p:sp>
+        <p:nvSpPr>
+          <p:cNvPr id="3" name="Title 2">
+            <a:extLst>
+              <a:ext uri="{FF2B5EF4-FFF2-40B4-BE49-F238E27FC236}">
+                <a16:creationId xmlns:a16="http://schemas.microsoft.com/office/drawing/2014/main" id="{839DED77-AC07-8439-3D65-A59625B6AC1F}"/>
+              </a:ext>
+            </a:extLst>
+          </p:cNvPr>
+          <p:cNvSpPr>
+            <a:spLocks noGrp="1"/>
+          </p:cNvSpPr>
+          <p:nvPr>
+            <p:ph type="title"/>
+          </p:nvPr>
+        </p:nvSpPr>
+        <p:spPr/>
+        <p:txBody>
+          <a:bodyPr/>
+          <a:lstStyle/>
+          <a:p>
+            <a:r>
+              <a:rPr lang="en-US" dirty="0"/>
+              <a:t>TCS Dictionary: Desired Semantics</a:t>
+            </a:r>
+          </a:p>
+        </p:txBody>
+      </p:sp>
+      <p:sp>
+        <p:nvSpPr>
+          <p:cNvPr id="4" name="Text Placeholder 3">
+            <a:extLst>
+              <a:ext uri="{FF2B5EF4-FFF2-40B4-BE49-F238E27FC236}">
+                <a16:creationId xmlns:a16="http://schemas.microsoft.com/office/drawing/2014/main" id="{575DA4B2-2627-1440-2751-387E8A17F5BB}"/>
+              </a:ext>
+            </a:extLst>
+          </p:cNvPr>
+          <p:cNvSpPr>
+            <a:spLocks noGrp="1"/>
+          </p:cNvSpPr>
+          <p:nvPr>
+            <p:ph type="body" sz="quarter" idx="10"/>
+          </p:nvPr>
+        </p:nvSpPr>
+        <p:spPr>
+          <a:xfrm>
+            <a:off x="269239" y="1197322"/>
+            <a:ext cx="11653522" cy="4366708"/>
+          </a:xfrm>
+        </p:spPr>
+        <p:txBody>
+          <a:bodyPr/>
+          <a:lstStyle/>
+          <a:p>
+            <a:r>
+              <a:rPr lang="en-US" dirty="0"/>
+              <a:t>Common situation: multiple requests and replies, where replies may not be in request order.</a:t>
+            </a:r>
+          </a:p>
+          <a:p>
+            <a:endParaRPr lang="en-US" dirty="0"/>
+          </a:p>
+          <a:p>
+            <a:r>
+              <a:rPr lang="en-US" dirty="0"/>
+              <a:t>Solution: TCS dictionary.</a:t>
+            </a:r>
+          </a:p>
+          <a:p>
+            <a:endParaRPr lang="en-US" dirty="0"/>
+          </a:p>
+          <a:p>
+            <a:r>
+              <a:rPr lang="en-US" dirty="0"/>
+              <a:t>Operations: Insert, Remove-And-Complete.</a:t>
+            </a:r>
+          </a:p>
+          <a:p>
+            <a:endParaRPr lang="en-US" dirty="0"/>
+          </a:p>
+          <a:p>
+            <a:r>
+              <a:rPr lang="en-US" b="1" dirty="0"/>
+              <a:t>Always complete your tasks!</a:t>
+            </a:r>
+          </a:p>
+        </p:txBody>
+      </p:sp>
+    </p:spTree>
+    <p:extLst>
+      <p:ext uri="{BB962C8B-B14F-4D97-AF65-F5344CB8AC3E}">
+        <p14:creationId xmlns:p14="http://schemas.microsoft.com/office/powerpoint/2010/main" val="1175680737"/>
+      </p:ext>
+    </p:extLst>
+  </p:cSld>
+  <p:clrMapOvr>
+    <a:masterClrMapping/>
+  </p:clrMapOvr>
+  <p:transition>
+    <p:fade/>
+  </p:transition>
+</p:sld>
+</file>
+
+<file path=ppt/slides/slide31.xml><?xml version="1.0" encoding="utf-8"?>
+<p:sld xmlns:a="http://schemas.openxmlformats.org/drawingml/2006/main" xmlns:r="http://schemas.openxmlformats.org/officeDocument/2006/relationships" xmlns:p="http://schemas.openxmlformats.org/presentationml/2006/main">
+  <p:cSld>
+    <p:spTree>
+      <p:nvGrpSpPr>
+        <p:cNvPr id="1" name=""/>
+        <p:cNvGrpSpPr/>
+        <p:nvPr/>
+      </p:nvGrpSpPr>
+      <p:grpSpPr>
+        <a:xfrm>
+          <a:off x="0" y="0"/>
+          <a:ext cx="0" cy="0"/>
+          <a:chOff x="0" y="0"/>
+          <a:chExt cx="0" cy="0"/>
+        </a:xfrm>
+      </p:grpSpPr>
       <p:pic>
         <p:nvPicPr>
           <p:cNvPr id="3" name="Picture 2">
@@ -8024,7 +8204,7 @@
 </p:sld>
 </file>
 
-<file path=ppt/slides/slide31.xml><?xml version="1.0" encoding="utf-8"?>
+<file path=ppt/slides/slide32.xml><?xml version="1.0" encoding="utf-8"?>
 <p:sld xmlns:a="http://schemas.openxmlformats.org/drawingml/2006/main" xmlns:r="http://schemas.openxmlformats.org/officeDocument/2006/relationships" xmlns:p="http://schemas.openxmlformats.org/presentationml/2006/main">
   <p:cSld>
     <p:spTree>
@@ -8208,7 +8388,7 @@
 </p:sld>
 </file>
 
-<file path=ppt/slides/slide32.xml><?xml version="1.0" encoding="utf-8"?>
+<file path=ppt/slides/slide33.xml><?xml version="1.0" encoding="utf-8"?>
 <p:sld xmlns:a="http://schemas.openxmlformats.org/drawingml/2006/main" xmlns:r="http://schemas.openxmlformats.org/officeDocument/2006/relationships" xmlns:p="http://schemas.openxmlformats.org/presentationml/2006/main">
   <p:cSld>
     <p:spTree>
@@ -8320,7 +8500,7 @@
 </p:sld>
 </file>
 
-<file path=ppt/slides/slide33.xml><?xml version="1.0" encoding="utf-8"?>
+<file path=ppt/slides/slide34.xml><?xml version="1.0" encoding="utf-8"?>
 <p:sld xmlns:a="http://schemas.openxmlformats.org/drawingml/2006/main" xmlns:r="http://schemas.openxmlformats.org/officeDocument/2006/relationships" xmlns:p="http://schemas.openxmlformats.org/presentationml/2006/main">
   <p:cSld>
     <p:spTree>
@@ -8476,7 +8656,7 @@
 </p:sld>
 </file>
 
-<file path=ppt/slides/slide34.xml><?xml version="1.0" encoding="utf-8"?>
+<file path=ppt/slides/slide35.xml><?xml version="1.0" encoding="utf-8"?>
 <p:sld xmlns:a="http://schemas.openxmlformats.org/drawingml/2006/main" xmlns:r="http://schemas.openxmlformats.org/officeDocument/2006/relationships" xmlns:p="http://schemas.openxmlformats.org/presentationml/2006/main">
   <p:cSld>
     <p:spTree>
@@ -8688,7 +8868,7 @@
 </p:sld>
 </file>
 
-<file path=ppt/slides/slide35.xml><?xml version="1.0" encoding="utf-8"?>
+<file path=ppt/slides/slide36.xml><?xml version="1.0" encoding="utf-8"?>
 <p:sld xmlns:a="http://schemas.openxmlformats.org/drawingml/2006/main" xmlns:r="http://schemas.openxmlformats.org/officeDocument/2006/relationships" xmlns:p="http://schemas.openxmlformats.org/presentationml/2006/main">
   <p:cSld>
     <p:spTree>
@@ -8749,7 +8929,7 @@
 </p:sld>
 </file>
 
-<file path=ppt/slides/slide36.xml><?xml version="1.0" encoding="utf-8"?>
+<file path=ppt/slides/slide37.xml><?xml version="1.0" encoding="utf-8"?>
 <p:sld xmlns:a="http://schemas.openxmlformats.org/drawingml/2006/main" xmlns:r="http://schemas.openxmlformats.org/officeDocument/2006/relationships" xmlns:p="http://schemas.openxmlformats.org/presentationml/2006/main">
   <p:cSld>
     <p:spTree>
@@ -9041,7 +9221,7 @@
 </p:sld>
 </file>
 
-<file path=ppt/slides/slide37.xml><?xml version="1.0" encoding="utf-8"?>
+<file path=ppt/slides/slide38.xml><?xml version="1.0" encoding="utf-8"?>
 <p:sld xmlns:a="http://schemas.openxmlformats.org/drawingml/2006/main" xmlns:r="http://schemas.openxmlformats.org/officeDocument/2006/relationships" xmlns:p="http://schemas.openxmlformats.org/presentationml/2006/main">
   <p:cSld>
     <p:spTree>
@@ -10050,6 +10230,128 @@
   <p:cSld>
     <p:spTree>
       <p:nvGrpSpPr>
+        <p:cNvPr id="1" name="">
+          <a:extLst>
+            <a:ext uri="{FF2B5EF4-FFF2-40B4-BE49-F238E27FC236}">
+              <a16:creationId xmlns:a16="http://schemas.microsoft.com/office/drawing/2014/main" id="{32B9B4F4-6B8F-797A-322D-7D316FD9968E}"/>
+            </a:ext>
+          </a:extLst>
+        </p:cNvPr>
+        <p:cNvGrpSpPr/>
+        <p:nvPr/>
+      </p:nvGrpSpPr>
+      <p:grpSpPr>
+        <a:xfrm>
+          <a:off x="0" y="0"/>
+          <a:ext cx="0" cy="0"/>
+          <a:chOff x="0" y="0"/>
+          <a:chExt cx="0" cy="0"/>
+        </a:xfrm>
+      </p:grpSpPr>
+      <p:sp>
+        <p:nvSpPr>
+          <p:cNvPr id="3" name="Title 2">
+            <a:extLst>
+              <a:ext uri="{FF2B5EF4-FFF2-40B4-BE49-F238E27FC236}">
+                <a16:creationId xmlns:a16="http://schemas.microsoft.com/office/drawing/2014/main" id="{AB343006-F9F5-2ABD-685B-946E5A082BC7}"/>
+              </a:ext>
+            </a:extLst>
+          </p:cNvPr>
+          <p:cNvSpPr>
+            <a:spLocks noGrp="1"/>
+          </p:cNvSpPr>
+          <p:nvPr>
+            <p:ph type="title"/>
+          </p:nvPr>
+        </p:nvSpPr>
+        <p:spPr/>
+        <p:txBody>
+          <a:bodyPr/>
+          <a:lstStyle/>
+          <a:p>
+            <a:r>
+              <a:rPr lang="en-US" dirty="0"/>
+              <a:t>Implementing </a:t>
+            </a:r>
+            <a:r>
+              <a:rPr lang="en-US" dirty="0" err="1"/>
+              <a:t>ValueTask</a:t>
+            </a:r>
+            <a:r>
+              <a:rPr lang="en-US" dirty="0"/>
+              <a:t> Methods</a:t>
+            </a:r>
+          </a:p>
+        </p:txBody>
+      </p:sp>
+      <p:sp>
+        <p:nvSpPr>
+          <p:cNvPr id="4" name="Text Placeholder 3">
+            <a:extLst>
+              <a:ext uri="{FF2B5EF4-FFF2-40B4-BE49-F238E27FC236}">
+                <a16:creationId xmlns:a16="http://schemas.microsoft.com/office/drawing/2014/main" id="{938B63F8-DB75-1DE3-568F-DE3644523647}"/>
+              </a:ext>
+            </a:extLst>
+          </p:cNvPr>
+          <p:cNvSpPr>
+            <a:spLocks noGrp="1"/>
+          </p:cNvSpPr>
+          <p:nvPr>
+            <p:ph type="body" sz="quarter" idx="10"/>
+          </p:nvPr>
+        </p:nvSpPr>
+        <p:spPr>
+          <a:xfrm>
+            <a:off x="269239" y="1197322"/>
+            <a:ext cx="11653522" cy="1030988"/>
+          </a:xfrm>
+        </p:spPr>
+        <p:txBody>
+          <a:bodyPr/>
+          <a:lstStyle/>
+          <a:p>
+            <a:pPr marL="457200" indent="-457200">
+              <a:buFontTx/>
+              <a:buChar char="-"/>
+            </a:pPr>
+            <a:r>
+              <a:rPr lang="en-US" dirty="0"/>
+              <a:t>Do nothing (keep using Task instead)</a:t>
+            </a:r>
+          </a:p>
+          <a:p>
+            <a:pPr marL="796926" lvl="1" indent="-457200">
+              <a:buFontTx/>
+              <a:buChar char="-"/>
+            </a:pPr>
+            <a:r>
+              <a:rPr lang="en-US" dirty="0"/>
+              <a:t>Just wait until runtime async lands.</a:t>
+            </a:r>
+          </a:p>
+        </p:txBody>
+      </p:sp>
+    </p:spTree>
+    <p:extLst>
+      <p:ext uri="{BB962C8B-B14F-4D97-AF65-F5344CB8AC3E}">
+        <p14:creationId xmlns:p14="http://schemas.microsoft.com/office/powerpoint/2010/main" val="2867021044"/>
+      </p:ext>
+    </p:extLst>
+  </p:cSld>
+  <p:clrMapOvr>
+    <a:masterClrMapping/>
+  </p:clrMapOvr>
+  <p:transition>
+    <p:fade/>
+  </p:transition>
+</p:sld>
+</file>
+
+<file path=ppt/slides/slide9.xml><?xml version="1.0" encoding="utf-8"?>
+<p:sld xmlns:a="http://schemas.openxmlformats.org/drawingml/2006/main" xmlns:r="http://schemas.openxmlformats.org/officeDocument/2006/relationships" xmlns:p="http://schemas.openxmlformats.org/presentationml/2006/main">
+  <p:cSld>
+    <p:spTree>
+      <p:nvGrpSpPr>
         <p:cNvPr id="1" name=""/>
         <p:cNvGrpSpPr/>
         <p:nvPr/>
@@ -10142,190 +10444,6 @@
     <p:extLst>
       <p:ext uri="{BB962C8B-B14F-4D97-AF65-F5344CB8AC3E}">
         <p14:creationId xmlns:p14="http://schemas.microsoft.com/office/powerpoint/2010/main" val="139230182"/>
-      </p:ext>
-    </p:extLst>
-  </p:cSld>
-  <p:clrMapOvr>
-    <a:masterClrMapping/>
-  </p:clrMapOvr>
-  <p:transition>
-    <p:fade/>
-  </p:transition>
-</p:sld>
-</file>
-
-<file path=ppt/slides/slide9.xml><?xml version="1.0" encoding="utf-8"?>
-<p:sld xmlns:a="http://schemas.openxmlformats.org/drawingml/2006/main" xmlns:r="http://schemas.openxmlformats.org/officeDocument/2006/relationships" xmlns:p="http://schemas.openxmlformats.org/presentationml/2006/main">
-  <p:cSld>
-    <p:spTree>
-      <p:nvGrpSpPr>
-        <p:cNvPr id="1" name=""/>
-        <p:cNvGrpSpPr/>
-        <p:nvPr/>
-      </p:nvGrpSpPr>
-      <p:grpSpPr>
-        <a:xfrm>
-          <a:off x="0" y="0"/>
-          <a:ext cx="0" cy="0"/>
-          <a:chOff x="0" y="0"/>
-          <a:chExt cx="0" cy="0"/>
-        </a:xfrm>
-      </p:grpSpPr>
-      <p:sp>
-        <p:nvSpPr>
-          <p:cNvPr id="2" name="Title 1">
-            <a:extLst>
-              <a:ext uri="{FF2B5EF4-FFF2-40B4-BE49-F238E27FC236}">
-                <a16:creationId xmlns:a16="http://schemas.microsoft.com/office/drawing/2014/main" id="{DE2CF484-0F47-554C-2FA2-668360593019}"/>
-              </a:ext>
-            </a:extLst>
-          </p:cNvPr>
-          <p:cNvSpPr>
-            <a:spLocks noGrp="1"/>
-          </p:cNvSpPr>
-          <p:nvPr>
-            <p:ph type="title"/>
-          </p:nvPr>
-        </p:nvSpPr>
-        <p:spPr/>
-        <p:txBody>
-          <a:bodyPr/>
-          <a:lstStyle/>
-          <a:p>
-            <a:r>
-              <a:rPr lang="en-US" dirty="0"/>
-              <a:t>Asynchronous Disposal</a:t>
-            </a:r>
-          </a:p>
-        </p:txBody>
-      </p:sp>
-      <p:sp>
-        <p:nvSpPr>
-          <p:cNvPr id="5" name="Text Placeholder 4">
-            <a:extLst>
-              <a:ext uri="{FF2B5EF4-FFF2-40B4-BE49-F238E27FC236}">
-                <a16:creationId xmlns:a16="http://schemas.microsoft.com/office/drawing/2014/main" id="{BBEE5FCE-DFD3-DCAC-06BC-BF9A8DAF3660}"/>
-              </a:ext>
-            </a:extLst>
-          </p:cNvPr>
-          <p:cNvSpPr>
-            <a:spLocks noGrp="1"/>
-          </p:cNvSpPr>
-          <p:nvPr>
-            <p:ph type="body" sz="quarter" idx="10"/>
-          </p:nvPr>
-        </p:nvSpPr>
-        <p:spPr>
-          <a:xfrm>
-            <a:off x="269239" y="1197322"/>
-            <a:ext cx="11653522" cy="4366708"/>
-          </a:xfrm>
-        </p:spPr>
-        <p:txBody>
-          <a:bodyPr/>
-          <a:lstStyle/>
-          <a:p>
-            <a:r>
-              <a:rPr lang="en-US" dirty="0" err="1">
-                <a:latin typeface="Consolas" panose="020B0609020204030204" pitchFamily="49" charset="0"/>
-              </a:rPr>
-              <a:t>ValueTask</a:t>
-            </a:r>
-            <a:r>
-              <a:rPr lang="en-US" dirty="0">
-                <a:latin typeface="Consolas" panose="020B0609020204030204" pitchFamily="49" charset="0"/>
-              </a:rPr>
-              <a:t> </a:t>
-            </a:r>
-            <a:r>
-              <a:rPr lang="en-US" dirty="0" err="1">
-                <a:latin typeface="Consolas" panose="020B0609020204030204" pitchFamily="49" charset="0"/>
-              </a:rPr>
-              <a:t>DisposeAsync</a:t>
-            </a:r>
-            <a:r>
-              <a:rPr lang="en-US" dirty="0">
-                <a:latin typeface="Consolas" panose="020B0609020204030204" pitchFamily="49" charset="0"/>
-              </a:rPr>
-              <a:t>();</a:t>
-            </a:r>
-          </a:p>
-          <a:p>
-            <a:endParaRPr lang="en-US" dirty="0"/>
-          </a:p>
-          <a:p>
-            <a:pPr marL="457200" indent="-457200">
-              <a:buFontTx/>
-              <a:buChar char="-"/>
-            </a:pPr>
-            <a:r>
-              <a:rPr lang="en-US" dirty="0"/>
-              <a:t>Just like </a:t>
-            </a:r>
-            <a:r>
-              <a:rPr lang="en-US" dirty="0">
-                <a:latin typeface="Consolas" panose="020B0609020204030204" pitchFamily="49" charset="0"/>
-              </a:rPr>
-              <a:t>Dispose()</a:t>
-            </a:r>
-            <a:r>
-              <a:rPr lang="en-US" dirty="0"/>
-              <a:t>, just asynchronous.</a:t>
-            </a:r>
-          </a:p>
-          <a:p>
-            <a:pPr marL="457200" indent="-457200">
-              <a:buFontTx/>
-              <a:buChar char="-"/>
-            </a:pPr>
-            <a:r>
-              <a:rPr lang="en-US" dirty="0"/>
-              <a:t>No official patterns for whether you can (or should) support both, “dispose pattern”, etc.</a:t>
-            </a:r>
-          </a:p>
-          <a:p>
-            <a:pPr marL="457200" indent="-457200">
-              <a:buFontTx/>
-              <a:buChar char="-"/>
-            </a:pPr>
-            <a:endParaRPr lang="en-US" dirty="0"/>
-          </a:p>
-          <a:p>
-            <a:r>
-              <a:rPr lang="en-US" dirty="0"/>
-              <a:t>Not supported everywhere, e.g., </a:t>
-            </a:r>
-            <a:r>
-              <a:rPr lang="en-US" dirty="0" err="1">
-                <a:latin typeface="Consolas" panose="020B0609020204030204" pitchFamily="49" charset="0"/>
-              </a:rPr>
-              <a:t>AsyncServiceScope</a:t>
-            </a:r>
-            <a:r>
-              <a:rPr lang="en-US" dirty="0"/>
-              <a:t> is 6.0+</a:t>
-            </a:r>
-          </a:p>
-          <a:p>
-            <a:pPr marL="457200" indent="-457200">
-              <a:buFontTx/>
-              <a:buChar char="-"/>
-            </a:pPr>
-            <a:r>
-              <a:rPr lang="en-US" dirty="0" err="1"/>
-              <a:t>Nito.Disposables</a:t>
-            </a:r>
-            <a:r>
-              <a:rPr lang="en-US" dirty="0"/>
-              <a:t> if you want helpers.</a:t>
-            </a:r>
-          </a:p>
-        </p:txBody>
-      </p:sp>
-    </p:spTree>
-    <p:extLst>
-      <p:ext uri="{BB962C8B-B14F-4D97-AF65-F5344CB8AC3E}">
-        <p14:creationId xmlns:p14="http://schemas.microsoft.com/office/powerpoint/2010/main" val="658538106"/>
       </p:ext>
     </p:extLst>
   </p:cSld>

</xml_diff>